<commit_message>
feat: rebuild lecture decks and lecturer notes
</commit_message>
<xml_diff>
--- a/IUEA_Teaching_Plan/decks/CML3111_Week01_Engineering.pptx
+++ b/IUEA_Teaching_Plan/decks/CML3111_Week01_Engineering.pptx
@@ -558,7 +558,7 @@
           <ns1:lstStyle/>
           <ns1:p>
             <ns1:r>
-              <ns1:t>Begin with a decision engineers make: estimate a quantity or identify a condition from observations. Today introduces the ideas using the embedded tables and illustrations; no CSV download or Python is needed. A prediction is an estimate, not proof that an action is safe.</ns1:t>
+              <ns1:t>Welcome to week one of Machine Learning. Today's session is called AI, machine learning and the engineering problem. This course introduces machine learning through electrical, mechatronic and communications examples. We start from zero. You do not need any programming experience for today, and we will explain every new word as we meet it. Check the slide for your day, time and room.</ns1:t>
             </ns1:r>
           </ns1:p>
         </ns0:txBody>
@@ -628,7 +628,19 @@
           <ns1:lstStyle/>
           <ns1:p>
             <ns1:r>
-              <ns1:t>This is a map of later topics, not an instruction to learn them all today. A roadmap puts tools and ideas in order. Distinguish the topics taught this semester from those deferred to Semester 2.</ns1:t>
+              <ns1:t>This is the second segment, and it lasts fifteen minutes. It is about the topics of machine learning, so it is a map of the whole field.</ns1:t>
+            </ns1:r>
+          </ns1:p>
+          <ns1:p/>
+          <ns1:p>
+            <ns1:r>
+              <ns1:t>A roadmap puts ideas and tools in order. It shows what comes first, what builds on what, and where you are going. The next slide shows a roadmap with fifteen stages. Some of those stages we cover in Semester 1, some belong to Semester 2, and some this course does not teach at all.</ns1:t>
+            </ns1:r>
+          </ns1:p>
+          <ns1:p/>
+          <ns1:p>
+            <ns1:r>
+              <ns1:t>You do not need to learn every item today. Your job in this segment is to see the whole landscape once, so that each later week has a place on the map.</ns1:t>
             </ns1:r>
           </ns1:p>
         </ns0:txBody>
@@ -698,7 +710,25 @@
           <ns1:lstStyle/>
           <ns1:p>
             <ns1:r>
-              <ns1:t>Define the terms in the context of today’s table. A dataset is a collection of data; it need not always be a table. An observation is one case; a target is needed for a supervised labelled example but may be missing for a new case awaiting prediction.</ns1:t>
+              <ns1:t>This is the first of three glossary slides. It lists the words we used today with short definitions.</ns1:t>
+            </ns1:r>
+          </ns1:p>
+          <ns1:p/>
+          <ns1:p>
+            <ns1:r>
+              <ns1:t>Artificial intelligence is any machine doing something we would call intelligent. It is a goal that many techniques aim at. Machine learning is inferring a rule from examples instead of writing it yourself. Deep learning is machine learning that uses large neural networks, and it belongs to Semester 2. Data science is the craft of getting a trustworthy answer out of data.</ns1:t>
+            </ns1:r>
+          </ns1:p>
+          <ns1:p/>
+          <ns1:p>
+            <ns1:r>
+              <ns1:t>A dataset is a collection of data. In this lesson we use tables of observations. An example, also called a row or an observation, is one recorded case. In supervised learning, an example includes its observed target.</ns1:t>
+            </ns1:r>
+          </ns1:p>
+          <ns1:p/>
+          <ns1:p>
+            <ns1:r>
+              <ns1:t>A feature is a column known before the outcome. It is an input to the prediction. The target, also called the label, is the column you are trying to predict.</ns1:t>
             </ns1:r>
           </ns1:p>
         </ns0:txBody>
@@ -768,7 +798,25 @@
           <ns1:lstStyle/>
           <ns1:p>
             <ns1:r>
-              <ns1:t>Differentiate prediction, observed value and error. Binary and multiclass refer to the number of categories, not to how category labels are stored. Unseen cases must also be relevant to intended use; an unrelated held-out set is not automatically a fair evaluation.</ns1:t>
+              <ns1:t>This is the second glossary slide.</ns1:t>
+            </ns1:r>
+          </ns1:p>
+          <ns1:p/>
+          <ns1:p>
+            <ns1:r>
+              <ns1:t>Regression means predicting a number on a continuous scale. Classification means predicting which of a small set of categories a case belongs to. Binary classification has exactly two categories, such as pass or fail. Multi-class classification has three or more categories.</ns1:t>
+            </ns1:r>
+          </ns1:p>
+          <ns1:p/>
+          <ns1:p>
+            <ns1:r>
+              <ns1:t>A prediction is the model's answer for a case. The error is the difference between the predicted value and the measured value.</ns1:t>
+            </ns1:r>
+          </ns1:p>
+          <ns1:p/>
+          <ns1:p>
+            <ns1:r>
+              <ns1:t>Unseen data means cases that were not used to fit the model. To be useful, they must also be relevant to the intended use and free from leakage. If you test a model on cases that look nothing like real use, a good score tells you very little.</ns1:t>
             </ns1:r>
           </ns1:p>
         </ns0:txBody>
@@ -838,7 +886,25 @@
           <ns1:lstStyle/>
           <ns1:p>
             <ns1:r>
-              <ns1:t>Follow the highlighted route from Python to data preparation and evaluation. Explain that a roadmap is a curriculum outline. Neural networks and transformers are later topics; no understanding of their internal mathematics is assumed here.</ns1:t>
+              <ns1:t>This is the roadmap for machine learning. It has fifteen stages, running from Python at the start to transformers at the end. A transformer is the type of model behind modern chatbots, and we only meet it much later.</ns1:t>
+            </ns1:r>
+          </ns1:p>
+          <ns1:p/>
+          <ns1:p>
+            <ns1:r>
+              <ns1:t>The colours carry the meaning. Orange stages are taught in Semester 1. Green stages are taught in Semester 2. Dark blue is the stage you already have from your engineering degree. Grey marks what this course deliberately does not teach.</ns1:t>
+            </ns1:r>
+          </ns1:p>
+          <ns1:p/>
+          <ns1:p>
+            <ns1:r>
+              <ns1:t>The shape follows the public roadmap dot sh Machine Learning roadmap, which is a free guide that many learners use.</ns1:t>
+            </ns1:r>
+          </ns1:p>
+          <ns1:p/>
+          <ns1:p>
+            <ns1:r>
+              <ns1:t>The orange stages are your route this semester. You start with Python, move to preparing data, and then reach building and testing models.</ns1:t>
             </ns1:r>
           </ns1:p>
         </ns0:txBody>
@@ -908,7 +974,31 @@
           <ns1:lstStyle/>
           <ns1:p>
             <ns1:r>
-              <ns1:t>Connect each foundation to its purpose. Arithmetic expresses measurements; statistics summarises variability; vectors and matrices arrange inputs; programming repeats a calculation. The course introduces the required operations before its worked examples.</ns1:t>
+              <ns1:t>Machine learning rests on two foundations, mathematics and programming. We will meet both, and we will not assume that you have mastered either.</ns1:t>
+            </ns1:r>
+          </ns1:p>
+          <ns1:p/>
+          <ns1:p>
+            <ns1:r>
+              <ns1:t>The roadmap lists calculus, which is the mathematics of change, linear algebra, which is working with lists and tables of numbers, statistics, which is summarising data, and probability, which measures how likely something is. Each one supports a different part of building or checking a model.</ns1:t>
+            </ns1:r>
+          </ns1:p>
+          <ns1:p/>
+          <ns1:p>
+            <ns1:r>
+              <ns1:t>We introduce only the mathematics that each topic needs, such as averages, matrices and probability, and each example shows the steps. Earlier mathematics courses may help, but you can follow without them.</ns1:t>
+            </ns1:r>
+          </ns1:p>
+          <ns1:p/>
+          <ns1:p>
+            <ns1:r>
+              <ns1:t>For programming, Weeks 2 to 6 introduce Python, data libraries and data preparation through worked examples. A library is a ready made collection of code that we borrow.</ns1:t>
+            </ns1:r>
+          </ns1:p>
+          <ns1:p/>
+          <ns1:p>
+            <ns1:r>
+              <ns1:t>Your engineering knowledge matters too. It helps you check units, judge whether a result is plausible, and see the limits of the data.</ns1:t>
             </ns1:r>
           </ns1:p>
         </ns0:txBody>
@@ -978,7 +1068,19 @@
           <ns1:lstStyle/>
           <ns1:p>
             <ns1:r>
-              <ns1:t>Read the coverage boundary literally. Topics outside the highlighted route are not hidden prerequisites for weekly work. Explain MLOps only as operating and monitoring deployed models; the full subject is outside this course.</ns1:t>
+              <ns1:t>The grey boxes on the roadmap are topics outside this course. They include reinforcement learning, full MLOps and most advanced language model topics.</ns1:t>
+            </ns1:r>
+          </ns1:p>
+          <ns1:p/>
+          <ns1:p>
+            <ns1:r>
+              <ns1:t>Reinforcement learning is a way for a program to learn by trying actions and receiving rewards. MLOps is the work of running a model in production, which means watching it and updating it after it has been deployed. Language models are the systems that work with text. We touch the idea, but we do not go deep.</ns1:t>
+            </ns1:r>
+          </ns1:p>
+          <ns1:p/>
+          <ns1:p>
+            <ns1:r>
+              <ns1:t>Read this boundary literally. If a topic sits outside the highlighted route, it is not a hidden prerequisite for any weekly task. Nobody will ask you to use it in an exercise or a test. Those topics exist, and you can study them later if you wish.</ns1:t>
             </ns1:r>
           </ns1:p>
         </ns0:txBody>
@@ -1048,7 +1150,25 @@
           <ns1:lstStyle/>
           <ns1:p>
             <ns1:r>
-              <ns1:t>Different roles emphasise different work: analysis explains data, data science investigates questions, ML engineering implements prediction systems, and data engineering supplies reliable data. The course builds introductory skills, not an immediate professional qualification.</ns1:t>
+              <ns1:t>Work with data splits into four different jobs. The slide calls them four different roadmaps and four different careers.</ns1:t>
+            </ns1:r>
+          </ns1:p>
+          <ns1:p/>
+          <ns1:p>
+            <ns1:r>
+              <ns1:t>A data analyst explains what the data shows. A data scientist investigates a question using data. A machine learning engineer builds and runs prediction systems. A data engineer makes sure that reliable data arrives where it is needed.</ns1:t>
+            </ns1:r>
+          </ns1:p>
+          <ns1:p/>
+          <ns1:p>
+            <ns1:r>
+              <ns1:t>Our course aims at the job of applying data skills inside your own engineering field. That is a narrower position, and it is a strong one. You bring engineering knowledge that computer science graduates do not have.</ns1:t>
+            </ns1:r>
+          </ns1:p>
+          <ns1:p/>
+          <ns1:p>
+            <ns1:r>
+              <ns1:t>The course gives you introductory skills in this area. It is a start and it does not replace a professional qualification.</ns1:t>
             </ns1:r>
           </ns1:p>
         </ns0:txBody>
@@ -1118,7 +1238,19 @@
           <ns1:lstStyle/>
           <ns1:p>
             <ns1:r>
-              <ns1:t>Move from job titles to the engineering question shown next. Start with the decision and available observations. Choosing a model before defining the question can produce an impressive score that does not help anyone.</ns1:t>
+              <ns1:t>This is the third segment, and it takes fifteen minutes. Three words are used as if they meant the same thing, and they do not. They are artificial intelligence, machine learning and data science.</ns1:t>
+            </ns1:r>
+          </ns1:p>
+          <ns1:p/>
+          <ns1:p>
+            <ns1:r>
+              <ns1:t>In this segment we separate them, and we place engineering among them. Each gets its own slide with a definition, an example and a common confusion.</ns1:t>
+            </ns1:r>
+          </ns1:p>
+          <ns1:p/>
+          <ns1:p>
+            <ns1:r>
+              <ns1:t>When we choose a method, we start from the decision that someone needs to make, and from the observations we already have. We choose a model after that. If you pick a model first, you can reach an impressive score that helps nobody.</ns1:t>
             </ns1:r>
           </ns1:p>
         </ns0:txBody>
@@ -1188,7 +1320,19 @@
           <ns1:lstStyle/>
           <ns1:p>
             <ns1:r>
-              <ns1:t>Explain the nested picture: machine learning is an approach within AI; deep learning is a family within machine learning. Data science overlaps these but also includes finding, checking, summarising and explaining data without training a model.</ns1:t>
+              <ns1:t>Three of these ideas nest inside one another: artificial intelligence, then machine learning, then deep learning. Data science sits outside that nesting. Artificial intelligence is the biggest circle. Machine learning is an approach inside artificial intelligence. Deep learning is a family of machine learning methods, and it uses large networks of simple calculations called neural networks. So each one is contained by the one before it.</ns1:t>
+            </ns1:r>
+          </ns1:p>
+          <ns1:p/>
+          <ns1:p>
+            <ns1:r>
+              <ns1:t>Data science is the odd one out. It overlaps all of them and is contained by none of them. Data science is the craft of getting an answer out of data at all. That includes finding the data, cleaning it, questioning it and presenting it.</ns1:t>
+            </ns1:r>
+          </ns1:p>
+          <ns1:p/>
+          <ns1:p>
+            <ns1:r>
+              <ns1:t>Much of that work involves no model whatever. A person who counts missing readings, checks units, and explains a trend is doing data science, even if no predictive model is ever built.</ns1:t>
             </ns1:r>
           </ns1:p>
         </ns0:txBody>
@@ -1258,7 +1402,25 @@
           <ns1:lstStyle/>
           <ns1:p>
             <ns1:r>
-              <ns1:t>AI is the broad area of systems performing tasks associated with intelligence. A fixed rule can be part of an AI system; AI does not always mean learning. Avoid implying that the system understands a problem as a person does.</ns1:t>
+              <ns1:t>Artificial intelligence means any machine doing something that we would call intelligent. It names a goal. Many different techniques aim at that goal.</ns1:t>
+            </ns1:r>
+          </ns1:p>
+          <ns1:p/>
+          <ns1:p>
+            <ns1:r>
+              <ns1:t>For example, a chess engine is artificial intelligence. So is a spam filter, which sorts unwanted email. A thermostat is not, because it follows one fixed rule and has no notion of doing better.</ns1:t>
+            </ns1:r>
+          </ns1:p>
+          <ns1:p/>
+          <ns1:p>
+            <ns1:r>
+              <ns1:t>This is easy to confuse with machine learning. Machine learning is one particular way of achieving artificial intelligence. All machine learning is artificial intelligence. Most artificial intelligence in history was never machine learning, because it ran on rules that people wrote by hand.</ns1:t>
+            </ns1:r>
+          </ns1:p>
+          <ns1:p/>
+          <ns1:p>
+            <ns1:r>
+              <ns1:t>So the phrase artificial intelligence tells you what someone wants to achieve. It does not tell you how they do it, and it does not mean that the system understands the problem the way a person does.</ns1:t>
             </ns1:r>
           </ns1:p>
         </ns0:txBody>
@@ -1328,7 +1490,19 @@
           <ns1:lstStyle/>
           <ns1:p>
             <ns1:r>
-              <ns1:t>A learning algorithm uses examples to adjust a model’s settings. We still choose the question, inputs and evaluation. The computer does not automatically discover a valid engineering law or decide whether its own prediction is safe.</ns1:t>
+              <ns1:t>Machine learning means getting a computer to work out a rule from examples..</ns1:t>
+            </ns1:r>
+          </ns1:p>
+          <ns1:p/>
+          <ns1:p>
+            <ns1:r>
+              <ns1:t>Here is an example. You show the computer ten thousand machine hours of sensor readings, and each period is labelled with whether a failure followed. The computer looks through all of these examples and infers a relationship between the readings and the outcome. After that, you decide whether to trust it. The computer does not decide that for you.</ns1:t>
+            </ns1:r>
+          </ns1:p>
+          <ns1:p/>
+          <ns1:p>
+            <ns1:r>
+              <ns1:t>Do not confuse machine learning with automation. A script that emails a report every Monday is automation. It does exactly what it was told, and there is no learning in it at all.</ns1:t>
             </ns1:r>
           </ns1:p>
         </ns0:txBody>
@@ -1398,7 +1572,19 @@
           <ns1:lstStyle/>
           <ns1:p>
             <ns1:r>
-              <ns1:t>Data science begins before modelling and continues after it. For example, counting missing sensor readings, checking units and explaining a trend are data-science work even if no predictive model is built.</ns1:t>
+              <ns1:t>Data science is the craft of getting a trustworthy answer out of data. The steps are finding the data, cleaning it, questioning it, analysing it, and presenting it so that somebody can act.</ns1:t>
+            </ns1:r>
+          </ns1:p>
+          <ns1:p/>
+          <ns1:p>
+            <ns1:r>
+              <ns1:t>For example, you might discover that a third of your sensor logs are missing. You then work out whether they are missing at random, or whether there is a reason, and you decide what that does to your conclusion. No model is involved in any of this work.</ns1:t>
+            </ns1:r>
+          </ns1:p>
+          <ns1:p/>
+          <ns1:p>
+            <ns1:r>
+              <ns1:t>Do not confuse data science with machine learning. You will spend far more of this semester on data science than on machine learning. That ratio matches professional practice, where most of the effort goes into getting the data right.</ns1:t>
             </ns1:r>
           </ns1:p>
         </ns0:txBody>
@@ -1468,7 +1654,25 @@
           <ns1:lstStyle/>
           <ns1:p>
             <ns1:r>
-              <ns1:t>Introduce the tutor’s applied data work briefly. The formal status is incoming PhD student in Applied Informatics at Osaka Metropolitan University, Japan, for April 2027; enrolment has not started. The examples illustrate different applications, not identical model architectures.</ns1:t>
+              <ns1:t>I am Jotham Martin Wambi, and I will be your lecturer for this course. By training I am a data scientist and machine learning engineer, and I am a founding engineer at Magentiq AI Labs.</ns1:t>
+            </ns1:r>
+          </ns1:p>
+          <ns1:p/>
+          <ns1:p>
+            <ns1:r>
+              <ns1:t>My background is in information technology and economics, with a master's degree in technology management from Yamaguchi University in Japan. I will start a PhD at Osaka Metropolitan University in April next year. Before that I worked for eight years at Citibank, at EY and at D'isum Inc in Tokyo.</ns1:t>
+            </ns1:r>
+          </ns1:p>
+          <ns1:p/>
+          <ns1:p>
+            <ns1:r>
+              <ns1:t>Here are three systems I have helped build. Law Lens is a system that answers questions about Ugandan law and shows where each answer came from. AssetGuard predicts when a machine will fail, using vibration sensors. The third reads a live heart signal from a wearable device and recognises eleven heart conditions.</ns1:t>
+            </ns1:r>
+          </ns1:p>
+          <ns1:p/>
+          <ns1:p>
+            <ns1:r>
+              <ns1:t>All three follow the same pipeline that you will build from Week 8. We split the data, fit a model, and then score it. My contact details are on the slide.</ns1:t>
             </ns1:r>
           </ns1:p>
         </ns0:txBody>
@@ -1538,7 +1742,19 @@
           <ns1:lstStyle/>
           <ns1:p>
             <ns1:r>
-              <ns1:t>Contrast a hand-specified rule with a rule fitted from examples. Both take inputs and produce an output; what differs is how the mapping is obtained. An established equation can be the better option when its assumptions apply.</ns1:t>
+              <ns1:t>This is the fourth segment, and it takes twenty five minutes. It is about two ways to make a computer decide something. Both ways take some inputs and produce an output. What differs is how the connection between the two is found.</ns1:t>
+            </ns1:r>
+          </ns1:p>
+          <ns1:p/>
+          <ns1:p>
+            <ns1:r>
+              <ns1:t>In the first way, a person writes the rule. In the second way, the computer learns the rule from examples of inputs and the answers that went with them. Learning patterns from data and using them to make predictions is the second way.</ns1:t>
+            </ns1:r>
+          </ns1:p>
+          <ns1:p/>
+          <ns1:p>
+            <ns1:r>
+              <ns1:t>Neither way is always better. If an established equation exists and its assumptions apply, the equation can be the better choice. We will work out together when each way fits.</ns1:t>
             </ns1:r>
           </ns1:p>
         </ns0:txBody>
@@ -1608,7 +1824,19 @@
           <ns1:lstStyle/>
           <ns1:p>
             <ns1:r>
-              <ns1:t>Identify the outcome, the information available beforehand, and the time at which a prediction would be useful. If an input is known only after the outcome, it cannot support that advance prediction. The following paper example illustrates the reasoning with small embedded data.</ns1:t>
+              <ns1:t>Here is the question this course starts from. This machine has three sensors on it. It failed last month. Could we have known?</ns1:t>
+            </ns1:r>
+          </ns1:p>
+          <ns1:p/>
+          <ns1:p>
+            <ns1:r>
+              <ns1:t>Keep that question in mind. Think about what you would need. You would need the outcome, which is the failure. You would need the information that existed before the failure. And you would need to know how far ahead a warning would still be useful.</ns1:t>
+            </ns1:r>
+          </ns1:p>
+          <ns1:p/>
+          <ns1:p>
+            <ns1:r>
+              <ns1:t>In twenty minutes you will answer a version of this question yourself. You will do it on paper, with a small table of numbers, with no computer and no formula.</ns1:t>
             </ns1:r>
           </ns1:p>
         </ns0:txBody>
@@ -1678,7 +1906,25 @@
           <ns1:lstStyle/>
           <ns1:p>
             <ns1:r>
-              <ns1:t>Trace the diagrams left to right. In conventional programming, a person supplies the rule. In supervised learning, past inputs and observed outcomes help an algorithm fit a rule. Then that fitted rule predicts outcomes for new inputs. Do not assume students have programmed before.</ns1:t>
+              <ns1:t>This slide shows the actual idea of the course. It compares two ways of working.</ns1:t>
+            </ns1:r>
+          </ns1:p>
+          <ns1:p/>
+          <ns1:p>
+            <ns1:r>
+              <ns1:t>The first is traditional programming. You work out the rule yourself and write it down. The computer takes your rule and some inputs, and it produces answers. If you know that power equals voltage times current, you can write that rule yourself.</ns1:t>
+            </ns1:r>
+          </ns1:p>
+          <ns1:p/>
+          <ns1:p>
+            <ns1:r>
+              <ns1:t>The second is machine learning. Here you do not know the rule. What you have are examples. Each example has the inputs and the answer that followed. You give both to the computer, and the computer works out a rule from them.</ns1:t>
+            </ns1:r>
+          </ns1:p>
+          <ns1:p/>
+          <ns1:p>
+            <ns1:r>
+              <ns1:t>After that, the rule it found can be used on new inputs, and it predicts the answers. So the roles are reversed. In traditional programming you supply the rule. In machine learning the computer supplies the rule, and you supply the examples.</ns1:t>
             </ns1:r>
           </ns1:p>
         </ns0:txBody>
@@ -1748,7 +1994,25 @@
           <ns1:lstStyle/>
           <ns1:p>
             <ns1:r>
-              <ns1:t>Explain the decision criteria one by one. Known equations still require valid units and assumptions. Learning from examples requires enough relevant data and evaluation on separate cases. Interpretability is a requirement to examine, not proof that every learned model is unexplainable.</ns1:t>
+              <ns1:t>How do you choose between the two ways? This slide gives you the criteria.</ns1:t>
+            </ns1:r>
+          </ns1:p>
+          <ns1:p/>
+          <ns1:p>
+            <ns1:r>
+              <ns1:t>Write the rule yourself when a code of practice, a datasheet or a validated equation already gives you the answer. Write it yourself when the relationship is simple and well understood. Write it yourself when you must explain every decision, line by line, to a client or a regulator. And write it yourself when you have little or no historical data.</ns1:t>
+            </ns1:r>
+          </ns1:p>
+          <ns1:p/>
+          <ns1:p>
+            <ns1:r>
+              <ns1:t>Let the computer infer the rule when nobody knows the rule, or it involves many variables acting on each other. Choose this when you have a reasonable number of past examples where you know both the inputs and the outcome. An early estimate can help with planning, if its error is small enough for the decision. Finally, you must be able to test the inferred rule on cases it has never seen.</ns1:t>
+            </ns1:r>
+          </ns1:p>
+          <ns1:p/>
+          <ns1:p>
+            <ns1:r>
+              <ns1:t>An equation still needs correct units and valid assumptions, so the check is always yours.</ns1:t>
             </ns1:r>
           </ns1:p>
         </ns0:txBody>
@@ -1818,7 +2082,19 @@
           <ns1:lstStyle/>
           <ns1:p>
             <ns1:r>
-              <ns1:t>Point to one complete row: it represents one observation. Read its column names and units before using any numbers. Identify candidate inputs available at prediction time, then the outcome to predict. The embedded table is the learning aid here; it is not a file students must locate.</ns1:t>
+              <ns1:t>Now we meet the vocabulary for data. Look at the table on the slide. Each row describes one case, which means one thing that was observed, such as one machine at one moment.</ns1:t>
+            </ns1:r>
+          </ns1:p>
+          <ns1:p/>
+          <ns1:p>
+            <ns1:r>
+              <ns1:t>The columns are the measurements. Some columns are the inputs. We call these the feature columns. They hold the information that we have available before we make a prediction. One column holds the value that we want to predict. We call that the target column.</ns1:t>
+            </ns1:r>
+          </ns1:p>
+          <ns1:p/>
+          <ns1:p>
+            <ns1:r>
+              <ns1:t>When you read any table, begin with the column names and the units. Then ask which columns you would really know in advance, and which one column is the answer. The table on the slide is part of the lesson, so there is no file to download or open.</ns1:t>
             </ns1:r>
           </ns1:p>
         </ns0:txBody>
@@ -1888,7 +2164,19 @@
           <ns1:lstStyle/>
           <ns1:p>
             <ns1:r>
-              <ns1:t>A feature is an input chosen for prediction; the target is the answer being predicted. Not every earlier measurement is useful, and an identifier may be only a label. Association means two quantities vary together; it does not establish that changing one causes the other.</ns1:t>
+              <ns1:t>A feature is a column whose value you know before the outcome. It is an input. The target is the column you want to predict. One row that holds all of them is called one example.</ns1:t>
+            </ns1:r>
+          </ns1:p>
+          <ns1:p/>
+          <ns1:p>
+            <ns1:r>
+              <ns1:t>In the table you just saw, rotational speed, torque and tool wear are the features. Whether the machine fails is the target.</ns1:t>
+            </ns1:r>
+          </ns1:p>
+          <ns1:p/>
+          <ns1:p>
+            <ns1:r>
+              <ns1:t>Be careful about the word cause. A target does not have to be a cause. Tool wear is associated with failure, which means the two tend to move together. The model learns that association. It knows nothing about metal fatigue, which is how metal actually weakens and breaks.</ns1:t>
             </ns1:r>
           </ns1:p>
         </ns0:txBody>
@@ -1958,7 +2246,31 @@
           <ns1:lstStyle/>
           <ns1:p>
             <ns1:r>
-              <ns1:t>Let students identify the target and exclude the post-outcome repair information. The reason is timing: information unavailable when predicting would leak the answer. A valid fixed formula is an acceptable alternative to ML. The next slide explains these answers.</ns1:t>
+              <ns1:t>Here are three questions to try before we look at the answers. Take a minute to think about each one and write something down.</ns1:t>
+            </ns1:r>
+          </ns1:p>
+          <ns1:p/>
+          <ns1:p>
+            <ns1:r>
+              <ns1:t>Question A. Take a table of records from the AI4I 2020 Predictive Maintenance data set. Is whether the machine fails a feature or the target?</ns1:t>
+            </ns1:r>
+          </ns1:p>
+          <ns1:p/>
+          <ns1:p>
+            <ns1:r>
+              <ns1:t>Question B. You want to predict how long a pump will run before it fails. You have a column that records the repair carried out afterwards. Should that column be a feature? Say why or why not. Think about when each piece of information becomes known.</ns1:t>
+            </ns1:r>
+          </ns1:p>
+          <ns1:p/>
+          <ns1:p>
+            <ns1:r>
+              <ns1:t>Question C. Give one example from your own discipline of a problem where you already know the rule, so machine learning would be the wrong tool.</ns1:t>
+            </ns1:r>
+          </ns1:p>
+          <ns1:p/>
+          <ns1:p>
+            <ns1:r>
+              <ns1:t>The answers are on the next slide. Try first, then look.</ns1:t>
             </ns1:r>
           </ns1:p>
         </ns0:txBody>
@@ -2028,7 +2340,31 @@
           <ns1:lstStyle/>
           <ns1:p>
             <ns1:r>
-              <ns1:t>Explain why the target is the requested outcome, not simply the last column. The repair-after-failure column is excluded because it would not be available beforehand. For electrical examples, Ohm’s law is V = IR; DC electrical power is P = VI. They are different relationships with different assumptions.</ns1:t>
+              <ns1:t>Let us check your answers.</ns1:t>
+            </ns1:r>
+          </ns1:p>
+          <ns1:p/>
+          <ns1:p>
+            <ns1:r>
+              <ns1:t>For A, the answer is the target. The target is the thing you want to predict. The measurements that you have available beforehand are the candidate features.</ns1:t>
+            </ns1:r>
+          </ns1:p>
+          <ns1:p/>
+          <ns1:p>
+            <ns1:r>
+              <ns1:t>For B, the repair column should not be a feature. The repair is recorded after the failure, so it is unavailable at the moment you need to predict. If you include it, your test results will look better than they should. This mistake has a name, data leakage. It means that information from the future has slipped into the inputs.</ns1:t>
+            </ns1:r>
+          </ns1:p>
+          <ns1:p/>
+          <ns1:p>
+            <ns1:r>
+              <ns1:t>For C, any problem with a formula or a code threshold works. For direct current circuits, power is voltage times current. Ohm's law says that voltage equals current times resistance. You do not need a model for either.</ns1:t>
+            </ns1:r>
+          </ns1:p>
+          <ns1:p/>
+          <ns1:p>
+            <ns1:r>
+              <ns1:t>If a validated equation exists, use the equation.</ns1:t>
             </ns1:r>
           </ns1:p>
         </ns0:txBody>
@@ -2098,7 +2434,25 @@
           <ns1:lstStyle/>
           <ns1:p>
             <ns1:r>
-              <ns1:t>Use the twelve embedded observations as known examples. Case 13 is withheld from the pattern-finding step. This is an individual paper exercise to practise prediction reasoning; it is not a requirement to write or train a model yet.</ns1:t>
+              <ns1:t>This is the fifth segment. It is hands on work and it takes twenty five minutes.</ns1:t>
+            </ns1:r>
+          </ns1:p>
+          <ns1:p/>
+          <ns1:p>
+            <ns1:r>
+              <ns1:t>You get a table with twelve rows. Each row is a case with its inputs and its measured outcome. A thirteenth case is also given, and for that case only the inputs are shown. Your job is to predict its outcome.</ns1:t>
+            </ns1:r>
+          </ns1:p>
+          <ns1:p/>
+          <ns1:p>
+            <ns1:r>
+              <ns1:t>Write down your prediction and explain which of the twelve rows helped you choose it. This is a paper exercise. You do not write code, and you do not train anything.</ns1:t>
+            </ns1:r>
+          </ns1:p>
+          <ns1:p/>
+          <ns1:p>
+            <ns1:r>
+              <ns1:t>The aim is a reasoned estimate. The aim is a reasoned estimate, and what we mark is the reason you give.</ns1:t>
             </ns1:r>
           </ns1:p>
         </ns0:txBody>
@@ -2168,7 +2522,25 @@
           <ns1:lstStyle/>
           <ns1:p>
             <ns1:r>
-              <ns1:t>Read the table’s headings and units first. Select similar known cases, make an estimate for case 13 and record a reason before the reveal. There is no requirement to form a team in class. The goal is an explained estimate, not guessing the exact measured answer.</ns1:t>
+              <ns1:t>Here is your task, and you have fifteen minutes for it. You work on your own.</ns1:t>
+            </ns1:r>
+          </ns1:p>
+          <ns1:p/>
+          <ns1:p>
+            <ns1:r>
+              <ns1:t>Twelve cases show their inputs and their measured outcomes. Case thirteen shows only its inputs. Predict the outcome of case thirteen, and write one sentence explaining your choice.</ns1:t>
+            </ns1:r>
+          </ns1:p>
+          <ns1:p/>
+          <ns1:p>
+            <ns1:r>
+              <ns1:t>Start by reading the column headings and the units. Then find the known cases that look most like case thirteen. Use them to make your estimate, and write your reason down before we reveal the true value.</ns1:t>
+            </ns1:r>
+          </ns1:p>
+          <ns1:p/>
+          <ns1:p>
+            <ns1:r>
+              <ns1:t>Writing your reason first matters. Afterwards you can compare what you expected with what was measured, and learn from the difference.</ns1:t>
             </ns1:r>
           </ns1:p>
         </ns0:txBody>
@@ -2238,7 +2610,25 @@
           <ns1:lstStyle/>
           <ns1:p>
             <ns1:r>
-              <ns1:t>Read the outcomes as questions learners should be able to answer by the end. Start with AI and machine learning in ordinary language; features, targets and task types are introduced later. Learners do not need those terms beforehand.</ns1:t>
+              <ns1:t>These are the seven things you should be able to do by the end of today. Read them as questions that you will be able to answer.</ns1:t>
+            </ns1:r>
+          </ns1:p>
+          <ns1:p/>
+          <ns1:p>
+            <ns1:r>
+              <ns1:t>We begin with words. You will be able to say what artificial intelligence, machine learning and data science each mean, and how they differ. Then you will explain the difference between writing a rule yourself and letting a computer work out a rule from examples.</ns1:t>
+            </ns1:r>
+          </ns1:p>
+          <ns1:p/>
+          <ns1:p>
+            <ns1:r>
+              <ns1:t>Next comes the data. You will look at a table and say which columns are the features, which are the inputs, and which column is the target, the thing we want to predict. You will also tell a regression problem, where the answer is a number, from a classification problem, where the answer is a category.</ns1:t>
+            </ns1:r>
+          </ns1:p>
+          <ns1:p/>
+          <ns1:p>
+            <ns1:r>
+              <ns1:t>Objective five asks you to name three problems in sensors, signals, energy systems, fault detection and machine health where data could help, and two where it could not. Objective six is to state four things machine learning cannot do, with a reason for each. Objective seven is to describe how the course is assessed and what your project will look like. Nothing today needs programming experience.</ns1:t>
             </ns1:r>
           </ns1:p>
         </ns0:txBody>
@@ -2308,7 +2698,31 @@
           <ns1:lstStyle/>
           <ns1:p>
             <ns1:r>
-              <ns1:t>Work through the five visible steps using the actual table. Interpolation estimates between neighbouring observations; it does not guarantee that the outcome lies between theirs. Explain why a second input may matter. Keep a record of the estimate before showing the measured outcome.</ns1:t>
+              <ns1:t>Let us read a pattern from the twelve cases. One approach is to compare cases that have similar inputs. Follow the five steps on the slide.</ns1:t>
+            </ns1:r>
+          </ns1:p>
+          <ns1:p/>
+          <ns1:p>
+            <ns1:r>
+              <ns1:t>Step one. Look down the columns and ask which column seems to move together with the outcome. Ignore the others for now.</ns1:t>
+            </ns1:r>
+          </ns1:p>
+          <ns1:p/>
+          <ns1:p>
+            <ns1:r>
+              <ns1:t>Step two. Find the two cases whose value in that column sits on either side of case thirteen's value. Step three. Look at their outcomes. The answer for case thirteen is probably between them. Estimating between two known points like this is called interpolation, and it is a good guess, though it is never a guarantee.</ns1:t>
+            </ns1:r>
+          </ns1:p>
+          <ns1:p/>
+          <ns1:p>
+            <ns1:r>
+              <ns1:t>Step four. Adjust for anything else you noticed, such as a second column that also seems to matter. Step five. Write the number down, write why, and ask how confident you are and what would change your mind.</ns1:t>
+            </ns1:r>
+          </ns1:p>
+          <ns1:p/>
+          <ns1:p>
+            <ns1:r>
+              <ns1:t>You have used a pattern in known examples to predict an unknown value. Comparing the prediction with the measured value tells you the size of the error.</ns1:t>
             </ns1:r>
           </ns1:p>
         </ns0:txBody>
@@ -2378,7 +2792,25 @@
           <ns1:lstStyle/>
           <ns1:p>
             <ns1:r>
-              <ns1:t>Read the star as the withheld observation and compare it with the previously recorded estimate. State the chosen signed-error convention before subtracting, and retain the measurement’s unit. Absolute error measures size without direction. One held-out case is not enough to establish reliable performance.</ns1:t>
+              <ns1:t>Here is the reveal. The chart shows the twelve known cases, and a star marks the measured value of case thirteen.</ns1:t>
+            </ns1:r>
+          </ns1:p>
+          <ns1:p/>
+          <ns1:p>
+            <ns1:r>
+              <ns1:t>The distance between your prediction and the star is the prediction error. It is the difference between what you predicted and what was measured. Keep the unit with it, because an error of three is meaningless until we know three of what. If we subtract in the same order each time. In this course we take the measured value minus the predicted value, a positive and a negative error will tell us whether we predicted too high or too low.</ns1:t>
+            </ns1:r>
+          </ns1:p>
+          <ns1:p/>
+          <ns1:p>
+            <ns1:r>
+              <ns1:t>The dashed line shows one possible pattern in the data. A line is only one kind of pattern, and other shapes are possible.</ns1:t>
+            </ns1:r>
+          </ns1:p>
+          <ns1:p/>
+          <ns1:p>
+            <ns1:r>
+              <ns1:t>One case cannot tell us how reliable a method is. With a single test we only see how it did this once. Later we will use many cases that were held back, and then the error means much more.</ns1:t>
             </ns1:r>
           </ns1:p>
         </ns0:txBody>
@@ -2448,7 +2880,25 @@
           <ns1:lstStyle/>
           <ns1:p>
             <ns1:r>
-              <ns1:t>Map the paper actions to later computing steps without claiming a computer was trained today. Looking at patterns is exploration; choosing columns is feature selection; an algorithm later fits model parameters. Separate evaluation asks whether the fitted rule works on observations it did not learn from.</ns1:t>
+              <ns1:t>Now we give names to what you just did. On the slide, the first group lists what you did, and the second group lists what it is called.</ns1:t>
+            </ns1:r>
+          </ns1:p>
+          <ns1:p/>
+          <ns1:p>
+            <ns1:r>
+              <ns1:t>You looked at the table. That is exploring the data, which we do in Weeks 5 and 6. You noticed which columns seemed to matter. That is selecting features, in Week 11. You worked out a rough rule in your head. That is proposing a model, and the Python models start in Week 8.</ns1:t>
+            </ns1:r>
+          </ns1:p>
+          <ns1:p/>
+          <ns1:p>
+            <ns1:r>
+              <ns1:t>You then applied your rule to a case that you had not seen. That is predicting for a case that was not used to find the pattern. Finally, you compared your prediction with the measured value. That is measuring the prediction error, and Week 10 covers model evaluation.</ns1:t>
+            </ns1:r>
+          </ns1:p>
+          <ns1:p/>
+          <ns1:p>
+            <ns1:r>
+              <ns1:t>So on paper, with twelve rows, you went through the same steps that a computer follows later. Nothing was trained today. Later weeks will repeat these steps in Python.</ns1:t>
             </ns1:r>
           </ns1:p>
         </ns0:txBody>
@@ -2518,7 +2968,13 @@
           <ns1:lstStyle/>
           <ns1:p>
             <ns1:r>
-              <ns1:t>Pause before introducing task types. No code or download is required for the second half of this introductory lesson.</ns1:t>
+              <ns1:t>We now take a ten minute break. Stand up, stretch and drink some water.</ns1:t>
+            </ns1:r>
+          </ns1:p>
+          <ns1:p/>
+          <ns1:p>
+            <ns1:r>
+              <ns1:t>When we come back, we move to the second half of the introduction. No computer is needed for the remaining examples, and no download or code is required. Come back on time, because we start with the two main kinds of prediction question.</ns1:t>
             </ns1:r>
           </ns1:p>
         </ns0:txBody>
@@ -2588,7 +3044,19 @@
           <ns1:lstStyle/>
           <ns1:p>
             <ns1:r>
-              <ns1:t>Explain that the kind of answer determines the task. An estimated amount is a regression target; a choice among categories is classification. Categories can be represented by numeric codes such as 0 and 1, so digits alone do not determine the task.</ns1:t>
+              <ns1:t>This is the sixth segment, and it lasts fifteen minutes. We look at two kinds of question. One is predicting a number, and the other is predicting a category. Almost everything in this course is one or the other.</ns1:t>
+            </ns1:r>
+          </ns1:p>
+          <ns1:p/>
+          <ns1:p>
+            <ns1:r>
+              <ns1:t>The kind of answer decides the task. If the answer is an amount, such as a torque or a number of days, the task is regression. If the answer is a choice from a list of labels, such as failure or no failure, the task is classification.</ns1:t>
+            </ns1:r>
+          </ns1:p>
+          <ns1:p/>
+          <ns1:p>
+            <ns1:r>
+              <ns1:t>Categories can be stored as numeric codes, like zero and one. The digits alone do not decide the task. What matters is what the answer means.</ns1:t>
             </ns1:r>
           </ns1:p>
         </ns0:txBody>
@@ -2658,7 +3126,19 @@
           <ns1:lstStyle/>
           <ns1:p>
             <ns1:r>
-              <ns1:t>The line is one possible regression model, not the definition of regression. Curved relationships are also possible. The boundary illustrates classification; it separates predicted categories. The same inputs may support different tasks depending on the target we define.</ns1:t>
+              <ns1:t>The slide shows the two shapes. In regression, the answer is a number on a continuous scale. A continuous scale means the value can be any amount between two points, such as any torque between ten and sixty newton metres. To handle this we fit a line or curve through the cases, and we read the prediction from it.</ns1:t>
+            </ns1:r>
+          </ns1:p>
+          <ns1:p/>
+          <ns1:p>
+            <ns1:r>
+              <ns1:t>In classification, the answer is one of a small set of labels. To handle this we look for a boundary that separates the labels, so that cases on one side get one label and cases on the other side get the other.</ns1:t>
+            </ns1:r>
+          </ns1:p>
+          <ns1:p/>
+          <ns1:p>
+            <ns1:r>
+              <ns1:t>The same data can often support both. If we take a column of measured temperatures, we can predict the temperature itself, which is regression, or we can predict whether it passes a safety limit, which is classification. The data stays the same. What changes is the question we ask, and so the target we choose.</ns1:t>
             </ns1:r>
           </ns1:p>
         </ns0:txBody>
@@ -2728,7 +3208,19 @@
           <ns1:lstStyle/>
           <ns1:p>
             <ns1:r>
-              <ns1:t>Ask what the output means, not only how it is written. A quantity such as torque or days is regression; a class such as failure/no failure is classification. A label encoded as 0 or 1 is still a category. Regression can also predict quantities without physical units.</ns1:t>
+              <ns1:t>Regression predicts a number on a continuous scale. Classification predicts which of a small number of categories a case belongs to.</ns1:t>
+            </ns1:r>
+          </ns1:p>
+          <ns1:p/>
+          <ns1:p>
+            <ns1:r>
+              <ns1:t>For example, a regression question is, how many newton metres of torque? A classification question is, failure or no failure. Another classification question is, which fault type, bearing, winding or imbalance? Imbalance means that a rotating part is not evenly weighted.</ns1:t>
+            </ns1:r>
+          </ns1:p>
+          <ns1:p/>
+          <ns1:p>
+            <ns1:r>
+              <ns1:t>To tell them apart, ask what the answer means. Estimating a quantity is regression. Choosing a category is classification. Categories may be stored as numeric codes such as zero and one, but they are still categories.</ns1:t>
             </ns1:r>
           </ns1:p>
         </ns0:txBody>
@@ -2798,7 +3290,31 @@
           <ns1:lstStyle/>
           <ns1:p>
             <ns1:r>
-              <ns1:t>Days until replacement is a numerical quantity. Pass/fail has two classes. Five fault types give multiclass classification. Identify the target meaning before choosing a method; students can answer without knowing a model algorithm.</ns1:t>
+              <ns1:t>Here is another check. Try each one before we show the answers.</ns1:t>
+            </ns1:r>
+          </ns1:p>
+          <ns1:p/>
+          <ns1:p>
+            <ns1:r>
+              <ns1:t>Question A. You want to predict how many days until a component needs replacing. Is that regression or classification?</ns1:t>
+            </ns1:r>
+          </ns1:p>
+          <ns1:p/>
+          <ns1:p>
+            <ns1:r>
+              <ns1:t>Question B. You want to predict whether a sample passes or fails a specification. Which one is it?</ns1:t>
+            </ns1:r>
+          </ns1:p>
+          <ns1:p/>
+          <ns1:p>
+            <ns1:r>
+              <ns1:t>Question C. You want to predict which of five fault types a machine has. Which one is it, and what makes it different from the previous question?</ns1:t>
+            </ns1:r>
+          </ns1:p>
+          <ns1:p/>
+          <ns1:p>
+            <ns1:r>
+              <ns1:t>Think about what each answer would look like. Is it a quantity, or is it a choice from a list? The answers are on the next slide.</ns1:t>
             </ns1:r>
           </ns1:p>
         </ns0:txBody>
@@ -2868,7 +3384,31 @@
           <ns1:lstStyle/>
           <ns1:p>
             <ns1:r>
-              <ns1:t>Explain binary as two categories and multiclass as more than two. More classes do not automatically make every dataset harder; difficulty also depends on their separation, examples and error costs. A confusion table will later reveal which categories are mixed up.</ns1:t>
+              <ns1:t>Let us see how you did.</ns1:t>
+            </ns1:r>
+          </ns1:p>
+          <ns1:p/>
+          <ns1:p>
+            <ns1:r>
+              <ns1:t>For A, days until replacement is regression. The answer is a number with a unit, which is days.</ns1:t>
+            </ns1:r>
+          </ns1:p>
+          <ns1:p/>
+          <ns1:p>
+            <ns1:r>
+              <ns1:t>For B, pass or fail is classification. There are two categories, so we call it binary classification. Binary means two.</ns1:t>
+            </ns1:r>
+          </ns1:p>
+          <ns1:p/>
+          <ns1:p>
+            <ns1:r>
+              <ns1:t>For C, five fault types is still classification, but it is multiclass instead of binary. Multiclass means more than two categories. A model with more categories is not automatically harder to build. The difficulty depends on how well the categories separate in the data, how many examples we have, and what each error costs.</ns1:t>
+            </ns1:r>
+          </ns1:p>
+          <ns1:p/>
+          <ns1:p>
+            <ns1:r>
+              <ns1:t>In Week 9 we study which categories get confused with each other, and that tells us much more than a single accuracy score.</ns1:t>
             </ns1:r>
           </ns1:p>
         </ns0:txBody>
@@ -2938,7 +3478,19 @@
           <ns1:lstStyle/>
           <ns1:p>
             <ns1:r>
-              <ns1:t>Introduce four reasons a prediction may not be useful. A model returning an answer is not evidence of data quality, a real predictive relationship or safe operation.</ns1:t>
+              <ns1:t>This is the seventh segment, and it takes fifteen minutes. We look at what machine learning cannot do. There are four limitations, and we will work through each of them.</ns1:t>
+            </ns1:r>
+          </ns1:p>
+          <ns1:p/>
+          <ns1:p>
+            <ns1:r>
+              <ns1:t>A model will always give you an answer. A returned prediction does not prove that the data was good, that a real relationship exists, or that an action is safe. So whenever you see a prediction, the next step is to ask whether the data and the testing really support the use that someone has in mind.</ns1:t>
+            </ns1:r>
+          </ns1:p>
+          <ns1:p/>
+          <ns1:p>
+            <ns1:r>
+              <ns1:t>The next two slides give the four limits, first in general terms and then in your own discipline.</ns1:t>
             </ns1:r>
           </ns1:p>
         </ns0:txBody>
@@ -3008,7 +3560,19 @@
           <ns1:lstStyle/>
           <ns1:p>
             <ns1:r>
-              <ns1:t>Explain the lesson’s sequence: define the ideas, inspect a worked example, then practise identifying a sensible prediction task. Timings are a guide, not a requirement to rush. The activities can be completed individually.</ns1:t>
+              <ns1:t>Every session this semester has the same shape, so you always know what is coming. Each session lasts three hours and is split into eleven segments.</ns1:t>
+            </ns1:r>
+          </ns1:p>
+          <ns1:p/>
+          <ns1:p>
+            <ns1:r>
+              <ns1:t>No stretch of talking from me runs longer than twenty five minutes. After each short explanation you do something yourself, such as answering a question, working through a small example or solving a problem on paper. Roughly half of every session is you doing and half is me explaining.</ns1:t>
+            </ns1:r>
+          </ns1:p>
+          <ns1:p/>
+          <ns1:p>
+            <ns1:r>
+              <ns1:t>Today's segments follow the same pattern. We define the main ideas, we work through an example together, and then you try one on your own. Use the segment slides to see where we are and how long each part should take.</ns1:t>
             </ns1:r>
           </ns1:p>
         </ns0:txBody>
@@ -3078,7 +3642,25 @@
           <ns1:lstStyle/>
           <ns1:p>
             <ns1:r>
-              <ns1:t>Walk through the four limits on the diagram: inadequate observations, weak or irrelevant inputs, a better known equation, and changes between past and current conditions. Explain that these are questions to investigate rather than universal claims about every plant or dataset.</ns1:t>
+              <ns1:t>These are four limits of machine learning, and none of them goes away with a better computer.</ns1:t>
+            </ns1:r>
+          </ns1:p>
+          <ns1:p/>
+          <ns1:p>
+            <ns1:r>
+              <ns1:t>First, there may be no data, or too few observations. A model can only learn from what has been recorded. Second, the inputs may carry no useful signal. They may be weak or irrelevant to the outcome. Third, a better method may already exist. A known physical equation can beat a model. Fourth, the future may change. Conditions today can differ from the conditions in the past data.</ns1:t>
+            </ns1:r>
+          </ns1:p>
+          <ns1:p/>
+          <ns1:p>
+            <ns1:r>
+              <ns1:t>A model can produce a prediction even when the data are unsuitable. It will not warn you. So for every problem, check whether the inputs and the testing support the use you intend.</ns1:t>
+            </ns1:r>
+          </ns1:p>
+          <ns1:p/>
+          <ns1:p>
+            <ns1:r>
+              <ns1:t>These four are questions to investigate for each plant and each data set. Each one is a question to investigate in each case.</ns1:t>
             </ns1:r>
           </ns1:p>
         </ns0:txBody>
@@ -3148,7 +3730,37 @@
           <ns1:lstStyle/>
           <ns1:p>
             <ns1:r>
-              <ns1:t>Treat each engineering situation as an illustrative scenario. Missing historical observations prevent learning that relationship from those observations. A superficially correlated label may fail elsewhere. A validated physical equation can be preferable. Changed equipment or materials can invalidate an old evaluation.</ns1:t>
+              <ns1:t>Here are the same four limits in your own discipline.</ns1:t>
+            </ns1:r>
+          </ns1:p>
+          <ns1:p/>
+          <ns1:p>
+            <ns1:r>
+              <ns1:t>One, no data. Most motors in most plants have no sensor on them at all, so there is nothing to learn from.</ns1:t>
+            </ns1:r>
+          </ns1:p>
+          <ns1:p/>
+          <ns1:p>
+            <ns1:r>
+              <ns1:t>Two, no signal. The paint colour of the cabinet does not predict bearing failure. If you feed it in, a model will still produce a number.</ns1:t>
+            </ns1:r>
+          </ns1:p>
+          <ns1:p/>
+          <ns1:p>
+            <ns1:r>
+              <ns1:t>Three, physics is better. For direct current circuits, power is voltage times current, and Ohm's law says that voltage equals current times resistance. Do not use a model where an equation will do.</ns1:t>
+            </ns1:r>
+          </ns1:p>
+          <ns1:p/>
+          <ns1:p>
+            <ns1:r>
+              <ns1:t>Four, the future changed. A model trained before a motor rewind or a firmware change may silently stop being true afterwards. A rewind means replacing the copper windings.</ns1:t>
+            </ns1:r>
+          </ns1:p>
+          <ns1:p/>
+          <ns1:p>
+            <ns1:r>
+              <ns1:t>This matters for the rest of the course. Every project in Week 9 has to survive these four questions before it is approved. A team that cannot answer them has not defined an engineering problem yet. It has picked a technique and gone looking for somewhere to use it.</ns1:t>
             </ns1:r>
           </ns1:p>
         </ns0:txBody>
@@ -3218,7 +3830,19 @@
           <ns1:lstStyle/>
           <ns1:p>
             <ns1:r>
-              <ns1:t>Introduce the Problem Hunt as practice defining a question before choosing a technique. It supports the A1 brief; it does not create another graded upload.</ns1:t>
+              <ns1:t>This is the eighth segment, and it takes thirty minutes. It is a challenge called the Problem Hunt.</ns1:t>
+            </ns1:r>
+          </ns1:p>
+          <ns1:p/>
+          <ns1:p>
+            <ns1:r>
+              <ns1:t>Your task is to read a problem and identify the information that is available. You then use the worked example to plan your first step. The skill we practise is defining a good question before choosing any technique.</ns1:t>
+            </ns1:r>
+          </ns1:p>
+          <ns1:p/>
+          <ns1:p>
+            <ns1:r>
+              <ns1:t>This exercise supports your Assignment A1 brief. It is practice, and it does not create another graded upload. A good answer may even conclude that an established rule is better than machine learning, and that is a perfectly good finding.</ns1:t>
             </ns1:r>
           </ns1:p>
         </ns0:txBody>
@@ -3288,7 +3912,25 @@
           <ns1:lstStyle/>
           <ns1:p>
             <ns1:r>
-              <ns1:t>Work through one candidate: specify the outcome, potential measurements, who records them, the decision helped and the cost of error. Then identify two other candidates. A good answer may conclude that an established rule is better than ML.</ns1:t>
+              <ns1:t>This is the Problem Hunt. There are three tasks.</ns1:t>
+            </ns1:r>
+          </ns1:p>
+          <ns1:p/>
+          <ns1:p>
+            <ns1:r>
+              <ns1:t>First, list three problems from sensors, signals, energy systems, fault detection and machine health where data might help. Second, classify each problem. Is it predicting a number, predicting a category, or something else? Explain your choice. Third, use the worked example as a guide, write down your assumptions, and explain your answer.</ns1:t>
+            </ns1:r>
+          </ns1:p>
+          <ns1:p/>
+          <ns1:p>
+            <ns1:r>
+              <ns1:t>Work through six questions in order. What do you want to predict? Who measures that, and how often? Would a rule you already know do this better? What would the answer let somebody do? How would you know if you were wrong? And what does a mistake cost here?</ns1:t>
+            </ns1:r>
+          </ns1:p>
+          <ns1:p/>
+          <ns1:p>
+            <ns1:r>
+              <ns1:t>Take one candidate problem and answer all six questions for it. Then repeat the process for the other two.</ns1:t>
             </ns1:r>
           </ns1:p>
         </ns0:txBody>
@@ -3358,7 +4000,25 @@
           <ns1:lstStyle/>
           <ns1:p>
             <ns1:r>
-              <ns1:t>Project teamwork is separate from today’s individual exercises. Explain rotating roles and the contribution log as specific records of who produced and explained each part. Individual written defence and reflection follow the current Week 15 brief; do not promise an unannounced live examination.</ns1:t>
+              <ns1:t>Now let us talk about how your team works all semester. Project teams have four or five people. You do two projects together. The first is a data analysis project, and the second is the Engineering ML Project, which runs from Week 9 to Week 15. The slide gives the due week for the first one.</ns1:t>
+            </ns1:r>
+          </ns1:p>
+          <ns1:p/>
+          <ns1:p>
+            <ns1:r>
+              <ns1:t>Roles rotate at every milestone. The roles are data analysis, modelling, engineering review, documentation and presentation. Rotating means each member practises different skills.</ns1:t>
+            </ns1:r>
+          </ns1:p>
+          <ns1:p/>
+          <ns1:p>
+            <ns1:r>
+              <ns1:t>Individual accountability is built in. Sixty five per cent of the mark is individual. Your team keeps a contribution log, which is a record of who did what, and I check it against the repository history. The repository is the online folder where your project files and their changes are stored. In Week 15, each student submits an individual written defence and reflection, following the published brief.</ns1:t>
+            </ns1:r>
+          </ns1:p>
+          <ns1:p/>
+          <ns1:p>
+            <ns1:r>
+              <ns1:t>Before you leave, sign the team charter. Write the names, contact details, a weekly meeting slot, and what you will do if somebody stops contributing. Agreeing that now is much easier than agreeing it in November.</ns1:t>
             </ns1:r>
           </ns1:p>
         </ns0:txBody>
@@ -3428,7 +4088,19 @@
           <ns1:lstStyle/>
           <ns1:p>
             <ns1:r>
-              <ns1:t>Review one candidate problem against the visible questions, then explain the A1 submission checklist. Do not require a gallery walk or peer boards. The assignment should be understandable to someone revising alone.</ns1:t>
+              <ns1:t>This is the ninth segment, and it takes ten minutes. We do two things.</ns1:t>
+            </ns1:r>
+          </ns1:p>
+          <ns1:p/>
+          <ns1:p>
+            <ns1:r>
+              <ns1:t>First, look again at your candidate problems from the Problem Hunt. Check one of them against the six questions on the earlier slide. Second, we review Assignment A1 and what you need to do to prepare for Week 2.</ns1:t>
+            </ns1:r>
+          </ns1:p>
+          <ns1:p/>
+          <ns1:p>
+            <ns1:r>
+              <ns1:t>The next slide explains A1 and the steps before next week. It is written so that someone reading it alone can follow it, so you can return to it when you are revising.</ns1:t>
             </ns1:r>
           </ns1:p>
         </ns0:txBody>
@@ -3498,7 +4170,31 @@
           <ns1:lstStyle/>
           <ns1:p>
             <ns1:r>
-              <ns1:t>A1 asks for one report covering three candidate problems and a justified choice of one. For each, identify inputs, target where appropriate, a possible data source and a limitation. Use the current form deadline. Account setup is preparation for Week 2, not a second report.</ns1:t>
+              <ns1:t>Here is Assignment A1, which you complete before Week 2. Use the deadline shown on the course form.</ns1:t>
+            </ns1:r>
+          </ns1:p>
+          <ns1:p/>
+          <ns1:p>
+            <ns1:r>
+              <ns1:t>You write about three candidate machine learning problems from your own discipline. For each one, state the inputs, the target, the data source and one limitation. Then choose one problem and its data set, and explain why it is feasible, meaning why it can really be done.</ns1:t>
+            </ns1:r>
+          </ns1:p>
+          <ns1:p/>
+          <ns1:p>
+            <ns1:r>
+              <ns1:t>The marks are six for framing, eight for data and six for judgement. Submit one DOCX file or one text PDF.</ns1:t>
+            </ns1:r>
+          </ns1:p>
+          <ns1:p/>
+          <ns1:p>
+            <ns1:r>
+              <ns1:t>Also before next week, create a GitHub account, which is a place to store project files online. Create a Google account if you do not have one, because we work in Google Colab from Week 2. Colab lets you write and run Python in a browser. Watch the video on the next slide. Sign and hand in your team charter.</ns1:t>
+            </ns1:r>
+          </ns1:p>
+          <ns1:p/>
+          <ns1:p>
+            <ns1:r>
+              <ns1:t>Do not install anything. Week 2 needs only a browser.</ns1:t>
             </ns1:r>
           </ns1:p>
         </ns0:txBody>
@@ -3568,7 +4264,25 @@
           <ns1:lstStyle/>
           <ns1:p>
             <ns1:r>
-              <ns1:t>The video is supplementary. Ask students to compare its definitions of AI, ML and deep learning with the lesson. Preview it before class; availability and suggested excerpt timings may change. Students can use the preceding explanations if the video is unavailable.</ns1:t>
+              <ns1:t>Please watch this video before Week 2. It comes from IBM Technology. Its title is AI, Machine Learning, Deep Learning and Generative AI Explained, and it runs for under ten minutes. The link is on the slide.</ns1:t>
+            </ns1:r>
+          </ns1:p>
+          <ns1:p/>
+          <ns1:p>
+            <ns1:r>
+              <ns1:t>As you watch, compare the speaker's definitions with the diagram we used today, where artificial intelligence contains machine learning, and machine learning contains deep learning. Note any terms that the speaker uses differently from us.</ns1:t>
+            </ns1:r>
+          </ns1:p>
+          <ns1:p/>
+          <ns1:p>
+            <ns1:r>
+              <ns1:t>Generative AI means systems that create new text, images or other content. We name it here, and we do not study it in Semester 1.</ns1:t>
+            </ns1:r>
+          </ns1:p>
+          <ns1:p/>
+          <ns1:p>
+            <ns1:r>
+              <ns1:t>If the video is unavailable, you can use today's slides for the same definitions.</ns1:t>
             </ns1:r>
           </ns1:p>
         </ns0:txBody>
@@ -3638,7 +4352,19 @@
           <ns1:lstStyle/>
           <ns1:p>
             <ns1:r>
-              <ns1:t>Explain how to revise: attempt the self-test before reading its answers, then use the glossary to clarify unfamiliar terms. The reference slides summarise this lesson; they do not introduce additional submission requirements.</ns1:t>
+              <ns1:t>This is the tenth segment, and it takes five minutes. Everything from here on is for you to study from.</ns1:t>
+            </ns1:r>
+          </ns1:p>
+          <ns1:p/>
+          <ns1:p>
+            <ns1:r>
+              <ns1:t>The slides that follow contain a summary, a self test with answers, a glossary, and a one page reference. Use them in that order when you revise. Attempt the self test first and write something for each question. Only then read the answers. Use the glossary whenever a word is unfamiliar.</ns1:t>
+            </ns1:r>
+          </ns1:p>
+          <ns1:p/>
+          <ns1:p>
+            <ns1:r>
+              <ns1:t>These slides recap today's lesson. They do not add any new submission.</ns1:t>
             </ns1:r>
           </ns1:p>
         </ns0:txBody>
@@ -3708,7 +4434,37 @@
           <ns1:lstStyle/>
           <ns1:p>
             <ns1:r>
-              <ns1:t>Recap the chain: engineering question, suitable observations, candidate inputs and target, method choice, evaluation and limitations. The row-and-column description applies to the supervised tables used here, not every possible dataset. Images, text and unlabelled data can have other structures.</ns1:t>
+              <ns1:t>Let us summarise what you should take away.</ns1:t>
+            </ns1:r>
+          </ns1:p>
+          <ns1:p/>
+          <ns1:p>
+            <ns1:r>
+              <ns1:t>Artificial intelligence is a goal. Machine learning is one way of reaching it. Data science is the craft of getting a trustworthy answer out of data at all.</ns1:t>
+            </ns1:r>
+          </ns1:p>
+          <ns1:p/>
+          <ns1:p>
+            <ns1:r>
+              <ns1:t>In traditional programming you write the rule. In machine learning you supply examples and the computer infers the rule, and then you must decide whether to trust it.</ns1:t>
+            </ns1:r>
+          </ns1:p>
+          <ns1:p/>
+          <ns1:p>
+            <ns1:r>
+              <ns1:t>The tables we used have one row per example, columns of candidate inputs, and an observed target. Other data sets can have different structures, such as images or text.</ns1:t>
+            </ns1:r>
+          </ns1:p>
+          <ns1:p/>
+          <ns1:p>
+            <ns1:r>
+              <ns1:t>Regression predicts a number with a unit. Classification predicts which of a small set of categories a case belongs to. The same data can pose either question.</ns1:t>
+            </ns1:r>
+          </ns1:p>
+          <ns1:p/>
+          <ns1:p>
+            <ns1:r>
+              <ns1:t>A model learns association. It does not learn cause, and a good fit is no evidence of a mechanism. Check for missing data, weak patterns, better physical models and changed conditions. A prediction alone does not show that a model is useful, so check the data, the errors and the limits of the intended use.</ns1:t>
             </ns1:r>
           </ns1:p>
         </ns0:txBody>
@@ -3778,7 +4534,25 @@
           <ns1:lstStyle/>
           <ns1:p>
             <ns1:r>
-              <ns1:t>Follow the semester from setup and Python to tables, cleaning, practical tests and models. Weeks 7 and 14 are test weeks. Test-day downloads and Colab submission follow the current test-entry instructions; do not substitute older offline-test guidance.</ns1:t>
+              <ns1:t>This slide shows the whole semester. It has fifteen weeks.</ns1:t>
+            </ns1:r>
+          </ns1:p>
+          <ns1:p/>
+          <ns1:p>
+            <ns1:r>
+              <ns1:t>The early weeks set you up and teach the basics of Python, which is the programming language we use, and how to prepare data. Weeks 7 and 14 are practical tests. In a practical test you are given a data set you have never seen before, and you are asked what you make of it. This tests whether you can work with real data. You prepare for it by doing the weekly exercises.</ns1:t>
+            </ns1:r>
+          </ns1:p>
+          <ns1:p/>
+          <ns1:p>
+            <ns1:r>
+              <ns1:t>The project runs from Week 9 to the last session. You will work on it in a team, and I will explain how teams work later today.</ns1:t>
+            </ns1:r>
+          </ns1:p>
+          <ns1:p/>
+          <ns1:p>
+            <ns1:r>
+              <ns1:t>Keep this slide in mind when you plan your own time. Check the slide for the weeks that matter most.</ns1:t>
             </ns1:r>
           </ns1:p>
         </ns0:txBody>
@@ -3848,7 +4622,43 @@
           <ns1:lstStyle/>
           <ns1:p>
             <ns1:r>
-              <ns1:t>Students should justify each answer. Features depend on what is known at prediction time. A score on training data can reflect memorisation. Before acting on a prediction, examine the error tolerance, operating conditions and consequences of mistakes.</ns1:t>
+              <ns1:t>This self test has five questions. Write something for each one before you look at the answers.</ns1:t>
+            </ns1:r>
+          </ns1:p>
+          <ns1:p/>
+          <ns1:p>
+            <ns1:r>
+              <ns1:t>Question A. A colleague says, we should use AI for this. What three questions would you ask before agreeing?</ns1:t>
+            </ns1:r>
+          </ns1:p>
+          <ns1:p/>
+          <ns1:p>
+            <ns1:r>
+              <ns1:t>Question B. You have a table of five hundred past pump repairs. Which columns are the features, which one is the target, and what tells you?</ns1:t>
+            </ns1:r>
+          </ns1:p>
+          <ns1:p/>
+          <ns1:p>
+            <ns1:r>
+              <ns1:t>Question C. Give one problem from your discipline that is regression, and one that is classification.</ns1:t>
+            </ns1:r>
+          </ns1:p>
+          <ns1:p/>
+          <ns1:p>
+            <ns1:r>
+              <ns1:t>Question D. Why is a very good fit on data that the model has already seen no evidence that the model is any good?</ns1:t>
+            </ns1:r>
+          </ns1:p>
+          <ns1:p/>
+          <ns1:p>
+            <ns1:r>
+              <ns1:t>Question E. Your model predicts shaft torque to within a few newton metres. Name one thing you would still need to know before acting on it.</ns1:t>
+            </ns1:r>
+          </ns1:p>
+          <ns1:p/>
+          <ns1:p>
+            <ns1:r>
+              <ns1:t>The answers are on the next slide.</ns1:t>
             </ns1:r>
           </ns1:p>
         </ns0:txBody>
@@ -3918,7 +4728,37 @@
           <ns1:lstStyle/>
           <ns1:p>
             <ns1:r>
-              <ns1:t>Use each answer to explain the reason. The target is determined by the question. Candidate features must be available beforehand and then checked for usefulness. Separate evaluation tests generalisation, but also needs relevant cases and protection against leakage.</ns1:t>
+              <ns1:t>Here are the answers.</ns1:t>
+            </ns1:r>
+          </ns1:p>
+          <ns1:p/>
+          <ns1:p>
+            <ns1:r>
+              <ns1:t>A. Ask what value you want to predict, which recorded data can help, and whether an established equation is suitable. Settle those questions before you choose a model.</ns1:t>
+            </ns1:r>
+          </ns1:p>
+          <ns1:p/>
+          <ns1:p>
+            <ns1:r>
+              <ns1:t>B. The target is whatever you want to predict, say the time to the next failure. The features are everything known before that moment, such as operating hours, load and temperature. The test is timing. Anything known only afterwards cannot be a feature.</ns1:t>
+            </ns1:r>
+          </ns1:p>
+          <ns1:p/>
+          <ns1:p>
+            <ns1:r>
+              <ns1:t>C. For regression, use any quantity with a unit, such as shaft torque in newton metres. For classification, use failure or no failure, or a fault type such as bearing, winding or imbalance.</ns1:t>
+            </ns1:r>
+          </ns1:p>
+          <ns1:p/>
+          <ns1:p>
+            <ns1:r>
+              <ns1:t>D. A model may memorise its training examples. To check whether it predicts new cases well, evaluate it on separate examples.</ns1:t>
+            </ns1:r>
+          </ns1:p>
+          <ns1:p/>
+          <ns1:p>
+            <ns1:r>
+              <ns1:t>E. You need to know how large the error is in engineering terms and whether that is tolerable, what it costs when the model is wrong, and whether today's conditions still resemble the data it learned from.</ns1:t>
             </ns1:r>
           </ns1:p>
         </ns0:txBody>
@@ -3988,7 +4828,25 @@
           <ns1:lstStyle/>
           <ns1:p>
             <ns1:r>
-              <ns1:t>Give a timing example for leakage: a repair recorded after failure is unavailable when predicting failure. Generalisation concerns new cases. Association alone does not establish causation; causal conclusions need additional assumptions or study design.</ns1:t>
+              <ns1:t>This is the last glossary slide, with three terms.</ns1:t>
+            </ns1:r>
+          </ns1:p>
+          <ns1:p/>
+          <ns1:p>
+            <ns1:r>
+              <ns1:t>Data leakage means accidentally giving the model information that it would not have in real use. Usually that is something only known after the outcome. The repair column from earlier is an example. We return to this in Week 10.</ns1:t>
+            </ns1:r>
+          </ns1:p>
+          <ns1:p/>
+          <ns1:p>
+            <ns1:r>
+              <ns1:t>Generalisation asks whether a rule learned from past cases still works on new ones. That is what we really care about.</ns1:t>
+            </ns1:r>
+          </ns1:p>
+          <ns1:p/>
+          <ns1:p>
+            <ns1:r>
+              <ns1:t>Association versus cause is the third. A model learns which columns move together. It knows nothing about the mechanism behind them. To show that one thing causes another, you need extra assumptions or a carefully designed study.</ns1:t>
             </ns1:r>
           </ns1:p>
         </ns0:txBody>
@@ -4058,7 +4916,25 @@
           <ns1:lstStyle/>
           <ns1:p>
             <ns1:r>
-              <ns1:t>Use the eight questions as a decision checklist. A prediction task needs an outcome, but descriptive data analysis can answer questions without a target. Check availability, evaluation and consequences before committing to a model.</ns1:t>
+              <ns1:t>This slide is a cheat sheet with eight questions to ask about any data problem. Keep this slide. You can use it for every project in this course.</ns1:t>
+            </ns1:r>
+          </ns1:p>
+          <ns1:p/>
+          <ns1:p>
+            <ns1:r>
+              <ns1:t>One, what exactly am I predicting? Name the target column and its unit. Two, is it a number or a category? Numeric class codes are still categories. Three, what do I know beforehand? List the features and check each one. Would I really have it before the outcome?</ns1:t>
+            </ns1:r>
+          </ns1:p>
+          <ns1:p/>
+          <ns1:p>
+            <ns1:r>
+              <ns1:t>Four, where does the data come from? Who measured it, how often, over what period, and is it kept anywhere? Five, would a rule or an equation do this better? If a code of practice or a validated formula answers it, use that.</ns1:t>
+            </ns1:r>
+          </ns1:p>
+          <ns1:p/>
+          <ns1:p>
+            <ns1:r>
+              <ns1:t>Six, how will I know if I am wrong? You need cases the model has never seen, so decide now how you will hold some back. Seven, what does being wrong cost? A false alarm and a missed failure are not equally bad, and that decides which model you pick. Eight, do today's conditions still resemble the data? If the process, material or plant has changed, the model may be quietly obsolete.</ns1:t>
             </ns1:r>
           </ns1:p>
         </ns0:txBody>
@@ -4128,7 +5004,19 @@
           <ns1:lstStyle/>
           <ns1:p>
             <ns1:r>
-              <ns1:t>Explain the difference between estimated completion time and availability: the quiz may take about five minutes, while its response window is 24 hours from lecturer activation. Use the cohort’s current quiz policy and the active link. The course’s quiz category remains 10% even where Quiz 6 is waived.</ns1:t>
+              <ns1:t>The Week 1 quiz has five questions and takes about five minutes. It covers features and target, regression and classification, and one of the four limits applied to a case.</ns1:t>
+            </ns1:r>
+          </ns1:p>
+          <ns1:p/>
+          <ns1:p>
+            <ns1:r>
+              <ns1:t>Enter your own Student Registration Number exactly as recorded. You have one attempt, from the Google account you are signed in to. The quiz opens when I activate it and stays open for twenty four hours.</ns1:t>
+            </ns1:r>
+          </ns1:p>
+          <ns1:p/>
+          <ns1:p>
+            <ns1:r>
+              <ns1:t>After you submit, tap View score and read the feedback. The quiz category is ten per cent, and your best ten of twelve count. Check the slide for the link.</ns1:t>
             </ns1:r>
           </ns1:p>
         </ns0:txBody>
@@ -4198,7 +5086,19 @@
           <ns1:lstStyle/>
           <ns1:p>
             <ns1:r>
-              <ns1:t>Close accurately: today learners practised reasoning from observations, making a prediction and checking error. Later Python lessons fit and evaluate models computationally. Bring a laptop and browser for Week 2; the introductory paper example is not an extra upload.</ns1:t>
+              <ns1:t>The one thing to remember from today is that you have practised prediction reasoning. You used twelve rows of data to make a prediction, and then you measured its error.</ns1:t>
+            </ns1:r>
+          </ns1:p>
+          <ns1:p/>
+          <ns1:p>
+            <ns1:r>
+              <ns1:t>Later lessons use Python to repeat these calculations on much larger data sets. The computer does the same kind of work that you did by hand, and it can do it for thousands of rows. Today's paper exercise is not an extra upload.</ns1:t>
+            </ns1:r>
+          </ns1:p>
+          <ns1:p/>
+          <ns1:p>
+            <ns1:r>
+              <ns1:t>Next week we start with Colab notebooks and version control. Bring a laptop with a browser.</ns1:t>
             </ns1:r>
           </ns1:p>
         </ns0:txBody>
@@ -4268,7 +5168,19 @@
           <ns1:lstStyle/>
           <ns1:p>
             <ns1:r>
-              <ns1:t>Connect each course goal to visible evidence: a runnable notebook, a correct summary, a reasoned chart or an evaluated model. Knowing a tool name is not the same as explaining a result. Engineering meaning and units remain part of every calculation.</ns1:t>
+              <ns1:t>By December you should be able to say several things with confidence, and this slide lists them. The course builds in order. First you learn to read data. Then you clean it and summarise it. Finally you build a model and test whether it works.</ns1:t>
+            </ns1:r>
+          </ns1:p>
+          <ns1:p/>
+          <ns1:p>
+            <ns1:r>
+              <ns1:t>Each week has an exercise that practises one stage of that route. You show what you can do. That means a notebook that runs, a summary that is correct, a chart whose reasoning you can explain, or a model whose results you have checked.</ns1:t>
+            </ns1:r>
+          </ns1:p>
+          <ns1:p/>
+          <ns1:p>
+            <ns1:r>
+              <ns1:t>In every calculation we also keep the engineering meaning, including the units. A number without a unit tells an engineer very little.</ns1:t>
             </ns1:r>
           </ns1:p>
         </ns0:txBody>
@@ -4338,7 +5250,19 @@
           <ns1:lstStyle/>
           <ns1:p>
             <ns1:r>
-              <ns1:t>Introduce how individual work and projects fit together. The next assessment slide supplies the components and weights. Separate weekly tasks from project milestones so students do not confuse one submission with another.</ns1:t>
+              <ns1:t>This is the first segment, and it lasts fifteen minutes. In it we cover three things. These are the goals of the course, how it is assessed, and the work you do each week.</ns1:t>
+            </ns1:r>
+          </ns1:p>
+          <ns1:p/>
+          <ns1:p>
+            <ns1:r>
+              <ns1:t>The course has two kinds of work. Some is individual, and some is done with a team in a project. We keep these separate so that you always know what you are submitting and who it is for. The next slide gives the assessment components and what each one is worth.</ns1:t>
+            </ns1:r>
+          </ns1:p>
+          <ns1:p/>
+          <ns1:p>
+            <ns1:r>
+              <ns1:t>A weekly task is a small piece of work. A project milestone is a stage of your team project. They are different, and you do not hand in one in place of the other.</ns1:t>
             </ns1:r>
           </ns1:p>
         </ns0:txBody>
@@ -4408,7 +5332,19 @@
           <ns1:lstStyle/>
           <ns1:p>
             <ns1:r>
-              <ns1:t>Walk through the displayed assessment components and add their weights to 100%. Explain which work is individual and which is a project. The current cohort waiver policy overrides old weekly counts: CML3112 and CML3113 have A6 and Quiz 6 waived; CML3111 retains them. Waived tasks do not become zeros.</ns1:t>
+              <ns1:t>Here is how your marks are built. Assessment includes code, data analysis, models and written explanations. So you will write short pieces of code, analyse data, build models, and explain in writing what you did and what you found.</ns1:t>
+            </ns1:r>
+          </ns1:p>
+          <ns1:p/>
+          <ns1:p>
+            <ns1:r>
+              <ns1:t>Individual work accounts for sixty five per cent of the mark. That means most of your result depends on what you can do yourself.</ns1:t>
+            </ns1:r>
+          </ns1:p>
+          <ns1:p/>
+          <ns1:p>
+            <ns1:r>
+              <ns1:t>The slide lists the components and their weights, and together they add up to one hundred per cent. Some weekly tasks and quizzes can differ by cohort, so check the details for your own class on the course page. Read the marking criteria for each piece of work before you start it.</ns1:t>
             </ns1:r>
           </ns1:p>
         </ns0:txBody>
@@ -4478,7 +5414,25 @@
           <ns1:lstStyle/>
           <ns1:p>
             <ns1:r>
-              <ns1:t>Explain reproducible work as work another person can rerun from the supplied files and instructions. Students should state sources, units and contributions. Asking for help is useful when the learner can show the attempted step and the exact error.</ns1:t>
+              <ns1:t>This slide sets out what I expect from you, and what you can expect from me.</ns1:t>
+            </ns1:r>
+          </ns1:p>
+          <ns1:p/>
+          <ns1:p>
+            <ns1:r>
+              <ns1:t>First, attend. There is one three hour session a week. The value is in the practical work and the challenge, and you cannot read that later. Second, do the weekly deliverable every week. Eleven small pieces spread over twelve weeks is manageable. Trying nine of them in December is not.</ns1:t>
+            </ns1:r>
+          </ns1:p>
+          <ns1:p/>
+          <ns1:p>
+            <ns1:r>
+              <ns1:t>When you ask for help, include the error message, what you tried and what you expected to happen. When you get stuck, note the step that failed and ask.</ns1:t>
+            </ns1:r>
+          </ns1:p>
+          <ns1:p/>
+          <ns1:p>
+            <ns1:r>
+              <ns1:t>From me, you get every marking scheme before the work is set, so you never meet a rubric for the first time in an assessment. You get feedback on weekly work within a week, and instant feedback on every quiz. I also ask you to download the lesson files before class so that you can use the data without an internet connection. And ask how each topic relates to your engineering problem.</ns1:t>
             </ns1:r>
           </ns1:p>
         </ns0:txBody>

</xml_diff>